<commit_message>
Add "Three Ways to Run It" delivery models to playbook page and deck
Adds a delivery-models section describing three ways to run the executive
program (Microsoft-led; we start you scale with train-the-trainer; partner-led)
to the markdown page (after How This Playbook Works) and a matching
"Three ways to run this" slide to the executive deck (now 27 slides).

Co-authored-by: Copilot <223556219+Copilot@users.noreply.github.com>
</commit_message>
<xml_diff>
--- a/education playground/assets/executive copilot playbook/Copilot-Premium-Executive-Training.pptx
+++ b/education playground/assets/executive copilot playbook/Copilot-Premium-Executive-Training.pptx
@@ -30,6 +30,7 @@
     <p:sldId id="274" r:id="rId20"/>
     <p:sldId id="281" r:id="rId28"/>
     <p:sldId id="282" r:id="rId33"/>
+    <p:sldId id="283" r:id="rId34"/>
     <p:sldId id="275" r:id="rId21"/>
   </p:sldIdLst>
   <p:notesMasterIdLst>
@@ -22967,6 +22968,1543 @@
               </a:rPr>
               <a:t>6</a:t>
             </a:r>
+          </a:p>
+        </p:txBody>
+      </p:sp>
+    </p:spTree>
+  </p:cSld>
+  <p:clrMapOvr>
+    <a:masterClrMapping/>
+  </p:clrMapOvr>
+</p:sld>
+</file>
+
+<file path=ppt/slides/slide28.xml><?xml version="1.0" encoding="utf-8"?>
+<p:sld xmlns:a="http://schemas.openxmlformats.org/drawingml/2006/main" xmlns:r="http://schemas.openxmlformats.org/officeDocument/2006/relationships" xmlns:p="http://schemas.openxmlformats.org/presentationml/2006/main">
+  <p:cSld name="Slide 3">
+    <p:bg>
+      <p:bgPr>
+        <a:solidFill>
+          <a:srgbClr val="F4F7FE"/>
+        </a:solidFill>
+      </p:bgPr>
+    </p:bg>
+    <p:spTree>
+      <p:nvGrpSpPr>
+        <p:cNvPr id="1" name=""/>
+        <p:cNvGrpSpPr/>
+        <p:nvPr/>
+      </p:nvGrpSpPr>
+      <p:grpSpPr>
+        <a:xfrm>
+          <a:off x="0" y="0"/>
+          <a:ext cx="0" cy="0"/>
+          <a:chOff x="0" y="0"/>
+          <a:chExt cx="0" cy="0"/>
+        </a:xfrm>
+      </p:grpSpPr>
+      <p:sp>
+        <p:nvSpPr>
+          <p:cNvPr id="2" name="Text 0"/>
+          <p:cNvSpPr/>
+          <p:nvPr/>
+        </p:nvSpPr>
+        <p:spPr>
+          <a:xfrm>
+            <a:off x="822960" y="566928"/>
+            <a:ext cx="8229600" cy="274320"/>
+          </a:xfrm>
+          <a:prstGeom prst="rect">
+            <a:avLst/>
+          </a:prstGeom>
+          <a:noFill/>
+          <a:ln/>
+        </p:spPr>
+        <p:txBody>
+          <a:bodyPr wrap="square" lIns="0" tIns="0" rIns="0" bIns="0" rtlCol="0" anchor="ctr"/>
+          <a:lstStyle/>
+          <a:p>
+            <a:pPr algn="l" indent="0" marL="0">
+              <a:buNone/>
+            </a:pPr>
+            <a:r>
+              <a:rPr lang="en-US" sz="1200" b="1" spc="300" kern="0" dirty="0">
+                <a:solidFill>
+                  <a:srgbClr val="2D6CDF"/>
+                </a:solidFill>
+                <a:latin typeface="Aptos" pitchFamily="34" charset="0"/>
+                <a:ea typeface="Aptos" pitchFamily="34" charset="-122"/>
+                <a:cs typeface="Aptos" pitchFamily="34" charset="-120"/>
+              </a:rPr>
+              <a:t>HOW TO BRING THIS TO YOUR LEADERS</a:t>
+            </a:r>
+            <a:endParaRPr lang="en-US" sz="1200" dirty="0"/>
+          </a:p>
+        </p:txBody>
+      </p:sp>
+      <p:sp>
+        <p:nvSpPr>
+          <p:cNvPr id="3" name="Text 1"/>
+          <p:cNvSpPr/>
+          <p:nvPr/>
+        </p:nvSpPr>
+        <p:spPr>
+          <a:xfrm>
+            <a:off x="786384" y="868680"/>
+            <a:ext cx="10972800" cy="594360"/>
+          </a:xfrm>
+          <a:prstGeom prst="rect">
+            <a:avLst/>
+          </a:prstGeom>
+          <a:noFill/>
+          <a:ln/>
+        </p:spPr>
+        <p:txBody>
+          <a:bodyPr wrap="square" lIns="0" tIns="0" rIns="0" bIns="0" rtlCol="0" anchor="ctr"/>
+          <a:lstStyle/>
+          <a:p>
+            <a:pPr indent="0" marL="0">
+              <a:buNone/>
+            </a:pPr>
+            <a:r>
+              <a:rPr lang="en-US" sz="3100" b="1" dirty="0">
+                <a:solidFill>
+                  <a:srgbClr val="0B1437"/>
+                </a:solidFill>
+                <a:latin typeface="Aptos" pitchFamily="34" charset="0"/>
+                <a:ea typeface="Aptos" pitchFamily="34" charset="-122"/>
+                <a:cs typeface="Aptos" pitchFamily="34" charset="-120"/>
+              </a:rPr>
+              <a:t>Three ways to run this</a:t>
+            </a:r>
+            <a:endParaRPr lang="en-US" sz="3100" dirty="0"/>
+          </a:p>
+        </p:txBody>
+      </p:sp>
+      <p:sp>
+        <p:nvSpPr>
+          <p:cNvPr id="4" name="Text 2"/>
+          <p:cNvSpPr/>
+          <p:nvPr/>
+        </p:nvSpPr>
+        <p:spPr>
+          <a:xfrm>
+            <a:off x="822960" y="1481328"/>
+            <a:ext cx="10607040" cy="365760"/>
+          </a:xfrm>
+          <a:prstGeom prst="rect">
+            <a:avLst/>
+          </a:prstGeom>
+          <a:noFill/>
+          <a:ln/>
+        </p:spPr>
+        <p:txBody>
+          <a:bodyPr wrap="square" lIns="0" tIns="0" rIns="0" bIns="0" rtlCol="0" anchor="ctr"/>
+          <a:lstStyle/>
+          <a:p>
+            <a:pPr indent="0" marL="0">
+              <a:buNone/>
+            </a:pPr>
+            <a:r>
+              <a:rPr lang="en-US" sz="1400" dirty="0">
+                <a:solidFill>
+                  <a:srgbClr val="43507B"/>
+                </a:solidFill>
+                <a:latin typeface="Aptos" pitchFamily="34" charset="0"/>
+                <a:ea typeface="Aptos" pitchFamily="34" charset="-122"/>
+                <a:cs typeface="Aptos" pitchFamily="34" charset="-120"/>
+              </a:rPr>
+              <a:t>Same framework, three speeds. You decide who carries it, and every asset is yours to download.</a:t>
+            </a:r>
+            <a:endParaRPr lang="en-US" sz="1400" dirty="0"/>
+          </a:p>
+        </p:txBody>
+      </p:sp>
+      <p:sp>
+        <p:nvSpPr>
+          <p:cNvPr id="5" name="Shape 3"/>
+          <p:cNvSpPr/>
+          <p:nvPr/>
+        </p:nvSpPr>
+        <p:spPr>
+          <a:xfrm>
+            <a:off x="822960" y="2834640"/>
+            <a:ext cx="3529584" cy="3108960"/>
+          </a:xfrm>
+          <a:prstGeom prst="roundRect">
+            <a:avLst>
+              <a:gd name="adj" fmla="val 2941"/>
+            </a:avLst>
+          </a:prstGeom>
+          <a:solidFill>
+            <a:srgbClr val="FFFFFF"/>
+          </a:solidFill>
+          <a:ln w="12700">
+            <a:solidFill>
+              <a:srgbClr val="E4E9F7"/>
+            </a:solidFill>
+            <a:prstDash val="solid"/>
+          </a:ln>
+          <a:effectLst>
+            <a:outerShdw sx="100000" sy="100000" kx="0" ky="0" algn="bl" rotWithShape="0" blurRad="114300" dist="38100" dir="5400000">
+              <a:srgbClr val="0B1437">
+                <a:alpha val="10000"/>
+              </a:srgbClr>
+            </a:outerShdw>
+          </a:effectLst>
+        </p:spPr>
+      </p:sp>
+      <p:sp>
+        <p:nvSpPr>
+          <p:cNvPr id="6" name="Shape 4"/>
+          <p:cNvSpPr/>
+          <p:nvPr/>
+        </p:nvSpPr>
+        <p:spPr>
+          <a:xfrm>
+            <a:off x="822960" y="2834640"/>
+            <a:ext cx="3529584" cy="128016"/>
+          </a:xfrm>
+          <a:prstGeom prst="rect">
+            <a:avLst/>
+          </a:prstGeom>
+          <a:solidFill>
+            <a:srgbClr val="2D6CDF"/>
+          </a:solidFill>
+          <a:ln/>
+        </p:spPr>
+      </p:sp>
+      <p:sp>
+        <p:nvSpPr>
+          <p:cNvPr id="7" name="Shape 5"/>
+          <p:cNvSpPr/>
+          <p:nvPr/>
+        </p:nvSpPr>
+        <p:spPr>
+          <a:xfrm>
+            <a:off x="1097280" y="3200400"/>
+            <a:ext cx="658368" cy="658368"/>
+          </a:xfrm>
+          <a:prstGeom prst="ellipse">
+            <a:avLst/>
+          </a:prstGeom>
+          <a:solidFill>
+            <a:srgbClr val="2D6CDF"/>
+          </a:solidFill>
+          <a:ln/>
+        </p:spPr>
+      </p:sp>
+      <p:sp>
+        <p:nvSpPr>
+          <p:cNvPr id="8" name="Text 6"/>
+          <p:cNvSpPr/>
+          <p:nvPr/>
+        </p:nvSpPr>
+        <p:spPr>
+          <a:xfrm>
+            <a:off x="1097280" y="3200400"/>
+            <a:ext cx="658368" cy="658368"/>
+          </a:xfrm>
+          <a:prstGeom prst="rect">
+            <a:avLst/>
+          </a:prstGeom>
+          <a:noFill/>
+          <a:ln/>
+        </p:spPr>
+        <p:txBody>
+          <a:bodyPr wrap="square" lIns="0" tIns="0" rIns="0" bIns="0" rtlCol="0" anchor="ctr"/>
+          <a:lstStyle/>
+          <a:p>
+            <a:pPr algn="ctr" indent="0" marL="0">
+              <a:buNone/>
+            </a:pPr>
+            <a:r>
+              <a:rPr lang="en-US" sz="3000" b="1" dirty="0">
+                <a:solidFill>
+                  <a:srgbClr val="FFFFFF"/>
+                </a:solidFill>
+                <a:latin typeface="Aptos" pitchFamily="34" charset="0"/>
+                <a:ea typeface="Aptos" pitchFamily="34" charset="-122"/>
+                <a:cs typeface="Aptos" pitchFamily="34" charset="-120"/>
+              </a:rPr>
+              <a:t>1</a:t>
+            </a:r>
+            <a:endParaRPr lang="en-US" sz="3000" dirty="0"/>
+          </a:p>
+        </p:txBody>
+      </p:sp>
+      <p:sp>
+        <p:nvSpPr>
+          <p:cNvPr id="9" name="Text 7"/>
+          <p:cNvSpPr/>
+          <p:nvPr/>
+        </p:nvSpPr>
+        <p:spPr>
+          <a:xfrm>
+            <a:off x="1920240" y="3236976"/>
+            <a:ext cx="2249424" cy="274320"/>
+          </a:xfrm>
+          <a:prstGeom prst="rect">
+            <a:avLst/>
+          </a:prstGeom>
+          <a:noFill/>
+          <a:ln/>
+        </p:spPr>
+        <p:txBody>
+          <a:bodyPr wrap="square" lIns="0" tIns="0" rIns="0" bIns="0" rtlCol="0" anchor="ctr"/>
+          <a:lstStyle/>
+          <a:p>
+            <a:pPr indent="0" marL="0">
+              <a:buNone/>
+            </a:pPr>
+            <a:r>
+              <a:rPr lang="en-US" sz="1200" b="1" spc="200" kern="0" dirty="0">
+                <a:solidFill>
+                  <a:srgbClr val="2D6CDF"/>
+                </a:solidFill>
+                <a:latin typeface="Aptos" pitchFamily="34" charset="0"/>
+                <a:ea typeface="Aptos" pitchFamily="34" charset="-122"/>
+                <a:cs typeface="Aptos" pitchFamily="34" charset="-120"/>
+              </a:rPr>
+              <a:t>MODEL 1</a:t>
+            </a:r>
+            <a:endParaRPr lang="en-US" sz="1200" dirty="0"/>
+          </a:p>
+        </p:txBody>
+      </p:sp>
+      <p:sp>
+        <p:nvSpPr>
+          <p:cNvPr id="10" name="Text 8"/>
+          <p:cNvSpPr/>
+          <p:nvPr/>
+        </p:nvSpPr>
+        <p:spPr>
+          <a:xfrm>
+            <a:off x="1920240" y="3493008"/>
+            <a:ext cx="2249424" cy="365760"/>
+          </a:xfrm>
+          <a:prstGeom prst="rect">
+            <a:avLst/>
+          </a:prstGeom>
+          <a:noFill/>
+          <a:ln/>
+        </p:spPr>
+        <p:txBody>
+          <a:bodyPr wrap="square" lIns="0" tIns="0" rIns="0" bIns="0" rtlCol="0" anchor="ctr"/>
+          <a:lstStyle/>
+          <a:p>
+            <a:pPr indent="0" marL="0">
+              <a:buNone/>
+            </a:pPr>
+            <a:r>
+              <a:rPr lang="en-US" sz="1900" b="1" dirty="0">
+                <a:solidFill>
+                  <a:srgbClr val="0B1437"/>
+                </a:solidFill>
+                <a:latin typeface="Aptos" pitchFamily="34" charset="0"/>
+                <a:ea typeface="Aptos" pitchFamily="34" charset="-122"/>
+                <a:cs typeface="Aptos" pitchFamily="34" charset="-120"/>
+              </a:rPr>
+              <a:t>Microsoft-led</a:t>
+            </a:r>
+            <a:endParaRPr lang="en-US" sz="1900" dirty="0"/>
+          </a:p>
+        </p:txBody>
+      </p:sp>
+      <p:sp>
+        <p:nvSpPr>
+          <p:cNvPr id="11" name="Text 9"/>
+          <p:cNvSpPr/>
+          <p:nvPr/>
+        </p:nvSpPr>
+        <p:spPr>
+          <a:xfrm>
+            <a:off x="1097280" y="4114800"/>
+            <a:ext cx="2980944" cy="292608"/>
+          </a:xfrm>
+          <a:prstGeom prst="rect">
+            <a:avLst/>
+          </a:prstGeom>
+          <a:noFill/>
+          <a:ln/>
+        </p:spPr>
+        <p:txBody>
+          <a:bodyPr wrap="square" lIns="0" tIns="0" rIns="0" bIns="0" rtlCol="0" anchor="ctr"/>
+          <a:lstStyle/>
+          <a:p>
+            <a:pPr indent="0" marL="0">
+              <a:buNone/>
+            </a:pPr>
+            <a:r>
+              <a:rPr lang="en-US" sz="1300" b="1" i="1" dirty="0">
+                <a:solidFill>
+                  <a:srgbClr val="8A93B8"/>
+                </a:solidFill>
+                <a:latin typeface="Aptos" pitchFamily="34" charset="0"/>
+                <a:ea typeface="Aptos" pitchFamily="34" charset="-122"/>
+                <a:cs typeface="Aptos" pitchFamily="34" charset="-120"/>
+              </a:rPr>
+              <a:t>The fastest, most guided path</a:t>
+            </a:r>
+            <a:endParaRPr lang="en-US" sz="1300" dirty="0"/>
+          </a:p>
+        </p:txBody>
+      </p:sp>
+      <p:sp>
+        <p:nvSpPr>
+          <p:cNvPr id="12" name="Shape 10"/>
+          <p:cNvSpPr/>
+          <p:nvPr/>
+        </p:nvSpPr>
+        <p:spPr>
+          <a:xfrm>
+            <a:off x="1133856" y="4572000"/>
+            <a:ext cx="128016" cy="128016"/>
+          </a:xfrm>
+          <a:prstGeom prst="ellipse">
+            <a:avLst/>
+          </a:prstGeom>
+          <a:solidFill>
+            <a:srgbClr val="2D6CDF"/>
+          </a:solidFill>
+          <a:ln/>
+        </p:spPr>
+      </p:sp>
+      <p:sp>
+        <p:nvSpPr>
+          <p:cNvPr id="13" name="Text 11"/>
+          <p:cNvSpPr/>
+          <p:nvPr/>
+        </p:nvSpPr>
+        <p:spPr>
+          <a:xfrm>
+            <a:off x="1371600" y="4480560"/>
+            <a:ext cx="2724912" cy="402336"/>
+          </a:xfrm>
+          <a:prstGeom prst="rect">
+            <a:avLst/>
+          </a:prstGeom>
+          <a:noFill/>
+          <a:ln/>
+        </p:spPr>
+        <p:txBody>
+          <a:bodyPr wrap="square" lIns="0" tIns="0" rIns="0" bIns="0" rtlCol="0" anchor="t"/>
+          <a:lstStyle/>
+          <a:p>
+            <a:pPr indent="0" marL="0">
+              <a:lnSpc>
+                <a:spcPct val="104000"/>
+              </a:lnSpc>
+              <a:buNone/>
+            </a:pPr>
+            <a:r>
+              <a:rPr lang="en-US" sz="1200" dirty="0">
+                <a:solidFill>
+                  <a:srgbClr val="43507B"/>
+                </a:solidFill>
+                <a:latin typeface="Aptos" pitchFamily="34" charset="0"/>
+                <a:ea typeface="Aptos" pitchFamily="34" charset="-122"/>
+                <a:cs typeface="Aptos" pitchFamily="34" charset="-120"/>
+              </a:rPr>
+              <a:t>Microsoft runs every session</a:t>
+            </a:r>
+            <a:endParaRPr lang="en-US" sz="1200" dirty="0"/>
+          </a:p>
+        </p:txBody>
+      </p:sp>
+      <p:sp>
+        <p:nvSpPr>
+          <p:cNvPr id="14" name="Shape 12"/>
+          <p:cNvSpPr/>
+          <p:nvPr/>
+        </p:nvSpPr>
+        <p:spPr>
+          <a:xfrm>
+            <a:off x="1133856" y="4877000"/>
+            <a:ext cx="128016" cy="128016"/>
+          </a:xfrm>
+          <a:prstGeom prst="ellipse">
+            <a:avLst/>
+          </a:prstGeom>
+          <a:solidFill>
+            <a:srgbClr val="2D6CDF"/>
+          </a:solidFill>
+          <a:ln/>
+        </p:spPr>
+      </p:sp>
+      <p:sp>
+        <p:nvSpPr>
+          <p:cNvPr id="15" name="Text 13"/>
+          <p:cNvSpPr/>
+          <p:nvPr/>
+        </p:nvSpPr>
+        <p:spPr>
+          <a:xfrm>
+            <a:off x="1371600" y="4785560"/>
+            <a:ext cx="2724912" cy="402336"/>
+          </a:xfrm>
+          <a:prstGeom prst="rect">
+            <a:avLst/>
+          </a:prstGeom>
+          <a:noFill/>
+          <a:ln/>
+        </p:spPr>
+        <p:txBody>
+          <a:bodyPr wrap="square" lIns="0" tIns="0" rIns="0" bIns="0" rtlCol="0" anchor="t"/>
+          <a:lstStyle/>
+          <a:p>
+            <a:pPr indent="0" marL="0">
+              <a:lnSpc>
+                <a:spcPct val="104000"/>
+              </a:lnSpc>
+              <a:buNone/>
+            </a:pPr>
+            <a:r>
+              <a:rPr lang="en-US" sz="1200" dirty="0">
+                <a:solidFill>
+                  <a:srgbClr val="43507B"/>
+                </a:solidFill>
+                <a:latin typeface="Aptos" pitchFamily="34" charset="0"/>
+                <a:ea typeface="Aptos" pitchFamily="34" charset="-122"/>
+                <a:cs typeface="Aptos" pitchFamily="34" charset="-120"/>
+              </a:rPr>
+              <a:t>With your leaders, start to finish</a:t>
+            </a:r>
+            <a:endParaRPr lang="en-US" sz="1200" dirty="0"/>
+          </a:p>
+        </p:txBody>
+      </p:sp>
+      <p:sp>
+        <p:nvSpPr>
+          <p:cNvPr id="16" name="Shape 14"/>
+          <p:cNvSpPr/>
+          <p:nvPr/>
+        </p:nvSpPr>
+        <p:spPr>
+          <a:xfrm>
+            <a:off x="1133856" y="5182000"/>
+            <a:ext cx="128016" cy="128016"/>
+          </a:xfrm>
+          <a:prstGeom prst="ellipse">
+            <a:avLst/>
+          </a:prstGeom>
+          <a:solidFill>
+            <a:srgbClr val="2D6CDF"/>
+          </a:solidFill>
+          <a:ln/>
+        </p:spPr>
+      </p:sp>
+      <p:sp>
+        <p:nvSpPr>
+          <p:cNvPr id="17" name="Text 15"/>
+          <p:cNvSpPr/>
+          <p:nvPr/>
+        </p:nvSpPr>
+        <p:spPr>
+          <a:xfrm>
+            <a:off x="1371600" y="5090560"/>
+            <a:ext cx="2724912" cy="402336"/>
+          </a:xfrm>
+          <a:prstGeom prst="rect">
+            <a:avLst/>
+          </a:prstGeom>
+          <a:noFill/>
+          <a:ln/>
+        </p:spPr>
+        <p:txBody>
+          <a:bodyPr wrap="square" lIns="0" tIns="0" rIns="0" bIns="0" rtlCol="0" anchor="t"/>
+          <a:lstStyle/>
+          <a:p>
+            <a:pPr indent="0" marL="0">
+              <a:lnSpc>
+                <a:spcPct val="104000"/>
+              </a:lnSpc>
+              <a:buNone/>
+            </a:pPr>
+            <a:r>
+              <a:rPr lang="en-US" sz="1200" dirty="0">
+                <a:solidFill>
+                  <a:srgbClr val="43507B"/>
+                </a:solidFill>
+                <a:latin typeface="Aptos" pitchFamily="34" charset="0"/>
+                <a:ea typeface="Aptos" pitchFamily="34" charset="-122"/>
+                <a:cs typeface="Aptos" pitchFamily="34" charset="-120"/>
+              </a:rPr>
+              <a:t>You host the room, we run it</a:t>
+            </a:r>
+            <a:endParaRPr lang="en-US" sz="1200" dirty="0"/>
+          </a:p>
+        </p:txBody>
+      </p:sp>
+      <p:sp>
+        <p:nvSpPr>
+          <p:cNvPr id="46" name="Shape 14"/>
+          <p:cNvSpPr/>
+          <p:nvPr/>
+        </p:nvSpPr>
+        <p:spPr>
+          <a:xfrm>
+            <a:off x="1133856" y="5487000"/>
+            <a:ext cx="128016" cy="128016"/>
+          </a:xfrm>
+          <a:prstGeom prst="ellipse">
+            <a:avLst/>
+          </a:prstGeom>
+          <a:solidFill>
+            <a:srgbClr val="2D6CDF"/>
+          </a:solidFill>
+          <a:ln/>
+        </p:spPr>
+      </p:sp>
+      <p:sp>
+        <p:nvSpPr>
+          <p:cNvPr id="47" name="Text 15"/>
+          <p:cNvSpPr/>
+          <p:nvPr/>
+        </p:nvSpPr>
+        <p:spPr>
+          <a:xfrm>
+            <a:off x="1371600" y="5395560"/>
+            <a:ext cx="2724912" cy="402336"/>
+          </a:xfrm>
+          <a:prstGeom prst="rect">
+            <a:avLst/>
+          </a:prstGeom>
+          <a:noFill/>
+          <a:ln/>
+        </p:spPr>
+        <p:txBody>
+          <a:bodyPr wrap="square" lIns="0" tIns="0" rIns="0" bIns="0" rtlCol="0" anchor="t"/>
+          <a:lstStyle/>
+          <a:p>
+            <a:pPr indent="0" marL="0">
+              <a:lnSpc>
+                <a:spcPct val="104000"/>
+              </a:lnSpc>
+              <a:buNone/>
+            </a:pPr>
+            <a:r>
+              <a:rPr lang="en-US" sz="1200" dirty="0">
+                <a:solidFill>
+                  <a:srgbClr val="43507B"/>
+                </a:solidFill>
+                <a:latin typeface="Aptos" pitchFamily="34" charset="0"/>
+                <a:ea typeface="Aptos" pitchFamily="34" charset="-122"/>
+                <a:cs typeface="Aptos" pitchFamily="34" charset="-120"/>
+              </a:rPr>
+              <a:t>Expert-led, lowest lift on you</a:t>
+            </a:r>
+            <a:endParaRPr lang="en-US" sz="1200" dirty="0"/>
+          </a:p>
+        </p:txBody>
+      </p:sp>
+      <p:sp>
+        <p:nvSpPr>
+          <p:cNvPr id="18" name="Shape 16"/>
+          <p:cNvSpPr/>
+          <p:nvPr/>
+        </p:nvSpPr>
+        <p:spPr>
+          <a:xfrm>
+            <a:off x="4517136" y="2560320"/>
+            <a:ext cx="3529584" cy="3383280"/>
+          </a:xfrm>
+          <a:prstGeom prst="roundRect">
+            <a:avLst>
+              <a:gd name="adj" fmla="val 2703"/>
+            </a:avLst>
+          </a:prstGeom>
+          <a:solidFill>
+            <a:srgbClr val="FFFFFF"/>
+          </a:solidFill>
+          <a:ln w="12700">
+            <a:solidFill>
+              <a:srgbClr val="E4E9F7"/>
+            </a:solidFill>
+            <a:prstDash val="solid"/>
+          </a:ln>
+          <a:effectLst>
+            <a:outerShdw sx="100000" sy="100000" kx="0" ky="0" algn="bl" rotWithShape="0" blurRad="114300" dist="38100" dir="5400000">
+              <a:srgbClr val="0B1437">
+                <a:alpha val="10000"/>
+              </a:srgbClr>
+            </a:outerShdw>
+          </a:effectLst>
+        </p:spPr>
+      </p:sp>
+      <p:sp>
+        <p:nvSpPr>
+          <p:cNvPr id="19" name="Shape 17"/>
+          <p:cNvSpPr/>
+          <p:nvPr/>
+        </p:nvSpPr>
+        <p:spPr>
+          <a:xfrm>
+            <a:off x="4517136" y="2560320"/>
+            <a:ext cx="3529584" cy="128016"/>
+          </a:xfrm>
+          <a:prstGeom prst="rect">
+            <a:avLst/>
+          </a:prstGeom>
+          <a:solidFill>
+            <a:srgbClr val="7C5CFC"/>
+          </a:solidFill>
+          <a:ln/>
+        </p:spPr>
+      </p:sp>
+      <p:sp>
+        <p:nvSpPr>
+          <p:cNvPr id="20" name="Shape 18"/>
+          <p:cNvSpPr/>
+          <p:nvPr/>
+        </p:nvSpPr>
+        <p:spPr>
+          <a:xfrm>
+            <a:off x="4791456" y="2926080"/>
+            <a:ext cx="658368" cy="658368"/>
+          </a:xfrm>
+          <a:prstGeom prst="ellipse">
+            <a:avLst/>
+          </a:prstGeom>
+          <a:solidFill>
+            <a:srgbClr val="7C5CFC"/>
+          </a:solidFill>
+          <a:ln/>
+        </p:spPr>
+      </p:sp>
+      <p:sp>
+        <p:nvSpPr>
+          <p:cNvPr id="21" name="Text 19"/>
+          <p:cNvSpPr/>
+          <p:nvPr/>
+        </p:nvSpPr>
+        <p:spPr>
+          <a:xfrm>
+            <a:off x="4791456" y="2926080"/>
+            <a:ext cx="658368" cy="658368"/>
+          </a:xfrm>
+          <a:prstGeom prst="rect">
+            <a:avLst/>
+          </a:prstGeom>
+          <a:noFill/>
+          <a:ln/>
+        </p:spPr>
+        <p:txBody>
+          <a:bodyPr wrap="square" lIns="0" tIns="0" rIns="0" bIns="0" rtlCol="0" anchor="ctr"/>
+          <a:lstStyle/>
+          <a:p>
+            <a:pPr algn="ctr" indent="0" marL="0">
+              <a:buNone/>
+            </a:pPr>
+            <a:r>
+              <a:rPr lang="en-US" sz="3000" b="1" dirty="0">
+                <a:solidFill>
+                  <a:srgbClr val="FFFFFF"/>
+                </a:solidFill>
+                <a:latin typeface="Aptos" pitchFamily="34" charset="0"/>
+                <a:ea typeface="Aptos" pitchFamily="34" charset="-122"/>
+                <a:cs typeface="Aptos" pitchFamily="34" charset="-120"/>
+              </a:rPr>
+              <a:t>2</a:t>
+            </a:r>
+            <a:endParaRPr lang="en-US" sz="3000" dirty="0"/>
+          </a:p>
+        </p:txBody>
+      </p:sp>
+      <p:sp>
+        <p:nvSpPr>
+          <p:cNvPr id="22" name="Text 20"/>
+          <p:cNvSpPr/>
+          <p:nvPr/>
+        </p:nvSpPr>
+        <p:spPr>
+          <a:xfrm>
+            <a:off x="5614416" y="2962656"/>
+            <a:ext cx="2249424" cy="274320"/>
+          </a:xfrm>
+          <a:prstGeom prst="rect">
+            <a:avLst/>
+          </a:prstGeom>
+          <a:noFill/>
+          <a:ln/>
+        </p:spPr>
+        <p:txBody>
+          <a:bodyPr wrap="square" lIns="0" tIns="0" rIns="0" bIns="0" rtlCol="0" anchor="ctr"/>
+          <a:lstStyle/>
+          <a:p>
+            <a:pPr indent="0" marL="0">
+              <a:buNone/>
+            </a:pPr>
+            <a:r>
+              <a:rPr lang="en-US" sz="1200" b="1" spc="200" kern="0" dirty="0">
+                <a:solidFill>
+                  <a:srgbClr val="7C5CFC"/>
+                </a:solidFill>
+                <a:latin typeface="Aptos" pitchFamily="34" charset="0"/>
+                <a:ea typeface="Aptos" pitchFamily="34" charset="-122"/>
+                <a:cs typeface="Aptos" pitchFamily="34" charset="-120"/>
+              </a:rPr>
+              <a:t>MODEL 2</a:t>
+            </a:r>
+            <a:endParaRPr lang="en-US" sz="1200" dirty="0"/>
+          </a:p>
+        </p:txBody>
+      </p:sp>
+      <p:sp>
+        <p:nvSpPr>
+          <p:cNvPr id="23" name="Text 21"/>
+          <p:cNvSpPr/>
+          <p:nvPr/>
+        </p:nvSpPr>
+        <p:spPr>
+          <a:xfrm>
+            <a:off x="5614416" y="3218688"/>
+            <a:ext cx="2249424" cy="365760"/>
+          </a:xfrm>
+          <a:prstGeom prst="rect">
+            <a:avLst/>
+          </a:prstGeom>
+          <a:noFill/>
+          <a:ln/>
+        </p:spPr>
+        <p:txBody>
+          <a:bodyPr wrap="square" lIns="0" tIns="0" rIns="0" bIns="0" rtlCol="0" anchor="ctr"/>
+          <a:lstStyle/>
+          <a:p>
+            <a:pPr indent="0" marL="0">
+              <a:buNone/>
+            </a:pPr>
+            <a:r>
+              <a:rPr lang="en-US" sz="1900" b="1" dirty="0">
+                <a:solidFill>
+                  <a:srgbClr val="0B1437"/>
+                </a:solidFill>
+                <a:latin typeface="Aptos" pitchFamily="34" charset="0"/>
+                <a:ea typeface="Aptos" pitchFamily="34" charset="-122"/>
+                <a:cs typeface="Aptos" pitchFamily="34" charset="-120"/>
+              </a:rPr>
+              <a:t>We start, you scale</a:t>
+            </a:r>
+            <a:endParaRPr lang="en-US" sz="1900" dirty="0"/>
+          </a:p>
+        </p:txBody>
+      </p:sp>
+      <p:sp>
+        <p:nvSpPr>
+          <p:cNvPr id="24" name="Text 22"/>
+          <p:cNvSpPr/>
+          <p:nvPr/>
+        </p:nvSpPr>
+        <p:spPr>
+          <a:xfrm>
+            <a:off x="4791456" y="3840480"/>
+            <a:ext cx="2980944" cy="292608"/>
+          </a:xfrm>
+          <a:prstGeom prst="rect">
+            <a:avLst/>
+          </a:prstGeom>
+          <a:noFill/>
+          <a:ln/>
+        </p:spPr>
+        <p:txBody>
+          <a:bodyPr wrap="square" lIns="0" tIns="0" rIns="0" bIns="0" rtlCol="0" anchor="ctr"/>
+          <a:lstStyle/>
+          <a:p>
+            <a:pPr indent="0" marL="0">
+              <a:buNone/>
+            </a:pPr>
+            <a:r>
+              <a:rPr lang="en-US" sz="1300" b="1" i="1" dirty="0">
+                <a:solidFill>
+                  <a:srgbClr val="8A93B8"/>
+                </a:solidFill>
+                <a:latin typeface="Aptos" pitchFamily="34" charset="0"/>
+                <a:ea typeface="Aptos" pitchFamily="34" charset="-122"/>
+                <a:cs typeface="Aptos" pitchFamily="34" charset="-120"/>
+              </a:rPr>
+              <a:t>When leader time is limited</a:t>
+            </a:r>
+            <a:endParaRPr lang="en-US" sz="1300" dirty="0"/>
+          </a:p>
+        </p:txBody>
+      </p:sp>
+      <p:sp>
+        <p:nvSpPr>
+          <p:cNvPr id="25" name="Shape 23"/>
+          <p:cNvSpPr/>
+          <p:nvPr/>
+        </p:nvSpPr>
+        <p:spPr>
+          <a:xfrm>
+            <a:off x="4828032" y="4297680"/>
+            <a:ext cx="128016" cy="128016"/>
+          </a:xfrm>
+          <a:prstGeom prst="ellipse">
+            <a:avLst/>
+          </a:prstGeom>
+          <a:solidFill>
+            <a:srgbClr val="7C5CFC"/>
+          </a:solidFill>
+          <a:ln/>
+        </p:spPr>
+      </p:sp>
+      <p:sp>
+        <p:nvSpPr>
+          <p:cNvPr id="26" name="Text 24"/>
+          <p:cNvSpPr/>
+          <p:nvPr/>
+        </p:nvSpPr>
+        <p:spPr>
+          <a:xfrm>
+            <a:off x="5065776" y="4206240"/>
+            <a:ext cx="2724912" cy="402336"/>
+          </a:xfrm>
+          <a:prstGeom prst="rect">
+            <a:avLst/>
+          </a:prstGeom>
+          <a:noFill/>
+          <a:ln/>
+        </p:spPr>
+        <p:txBody>
+          <a:bodyPr wrap="square" lIns="0" tIns="0" rIns="0" bIns="0" rtlCol="0" anchor="t"/>
+          <a:lstStyle/>
+          <a:p>
+            <a:pPr indent="0" marL="0">
+              <a:lnSpc>
+                <a:spcPct val="104000"/>
+              </a:lnSpc>
+              <a:buNone/>
+            </a:pPr>
+            <a:r>
+              <a:rPr lang="en-US" sz="1200" dirty="0">
+                <a:solidFill>
+                  <a:srgbClr val="43507B"/>
+                </a:solidFill>
+                <a:latin typeface="Aptos" pitchFamily="34" charset="0"/>
+                <a:ea typeface="Aptos" pitchFamily="34" charset="-122"/>
+                <a:cs typeface="Aptos" pitchFamily="34" charset="-120"/>
+              </a:rPr>
+              <a:t>We run the foundation live</a:t>
+            </a:r>
+            <a:endParaRPr lang="en-US" sz="1200" dirty="0"/>
+          </a:p>
+        </p:txBody>
+      </p:sp>
+      <p:sp>
+        <p:nvSpPr>
+          <p:cNvPr id="27" name="Shape 25"/>
+          <p:cNvSpPr/>
+          <p:nvPr/>
+        </p:nvSpPr>
+        <p:spPr>
+          <a:xfrm>
+            <a:off x="4828032" y="4754880"/>
+            <a:ext cx="128016" cy="128016"/>
+          </a:xfrm>
+          <a:prstGeom prst="ellipse">
+            <a:avLst/>
+          </a:prstGeom>
+          <a:solidFill>
+            <a:srgbClr val="7C5CFC"/>
+          </a:solidFill>
+          <a:ln/>
+        </p:spPr>
+      </p:sp>
+      <p:sp>
+        <p:nvSpPr>
+          <p:cNvPr id="28" name="Text 26"/>
+          <p:cNvSpPr/>
+          <p:nvPr/>
+        </p:nvSpPr>
+        <p:spPr>
+          <a:xfrm>
+            <a:off x="5065776" y="4663440"/>
+            <a:ext cx="2724912" cy="402336"/>
+          </a:xfrm>
+          <a:prstGeom prst="rect">
+            <a:avLst/>
+          </a:prstGeom>
+          <a:noFill/>
+          <a:ln/>
+        </p:spPr>
+        <p:txBody>
+          <a:bodyPr wrap="square" lIns="0" tIns="0" rIns="0" bIns="0" rtlCol="0" anchor="t"/>
+          <a:lstStyle/>
+          <a:p>
+            <a:pPr indent="0" marL="0">
+              <a:lnSpc>
+                <a:spcPct val="104000"/>
+              </a:lnSpc>
+              <a:buNone/>
+            </a:pPr>
+            <a:r>
+              <a:rPr lang="en-US" sz="1200" dirty="0">
+                <a:solidFill>
+                  <a:srgbClr val="43507B"/>
+                </a:solidFill>
+                <a:latin typeface="Aptos" pitchFamily="34" charset="0"/>
+                <a:ea typeface="Aptos" pitchFamily="34" charset="-122"/>
+                <a:cs typeface="Aptos" pitchFamily="34" charset="-120"/>
+              </a:rPr>
+              <a:t>Plus tailored exec one-on-ones</a:t>
+            </a:r>
+            <a:endParaRPr lang="en-US" sz="1200" dirty="0"/>
+          </a:p>
+        </p:txBody>
+      </p:sp>
+      <p:sp>
+        <p:nvSpPr>
+          <p:cNvPr id="90001" name="Text 26c"/>
+          <p:cNvSpPr/>
+          <p:nvPr/>
+        </p:nvSpPr>
+        <p:spPr>
+          <a:xfrm>
+            <a:off x="5065776" y="5120640"/>
+            <a:ext cx="2724912" cy="402336"/>
+          </a:xfrm>
+          <a:prstGeom prst="rect">
+            <a:avLst/>
+          </a:prstGeom>
+          <a:noFill/>
+          <a:ln/>
+        </p:spPr>
+        <p:txBody>
+          <a:bodyPr wrap="square" lIns="0" tIns="0" rIns="0" bIns="0" rtlCol="0" anchor="t"/>
+          <a:lstStyle/>
+          <a:p>
+            <a:pPr indent="0" marL="0">
+              <a:lnSpc>
+                <a:spcPct val="104000"/>
+              </a:lnSpc>
+              <a:buNone/>
+            </a:pPr>
+            <a:r>
+              <a:rPr lang="en-US" sz="1200" dirty="0">
+                <a:solidFill>
+                  <a:srgbClr val="43507B"/>
+                </a:solidFill>
+                <a:latin typeface="Aptos" pitchFamily="34" charset="0"/>
+                <a:ea typeface="Aptos" pitchFamily="34" charset="-122"/>
+                <a:cs typeface="Aptos" pitchFamily="34" charset="-120"/>
+              </a:rPr>
+              <a:t>We train your trainers on the rest</a:t>
+            </a:r>
+            <a:endParaRPr lang="en-US" sz="1200" dirty="0"/>
+          </a:p>
+        </p:txBody>
+      </p:sp>
+      <p:sp>
+        <p:nvSpPr>
+          <p:cNvPr id="90002" name="Shape 25c"/>
+          <p:cNvSpPr/>
+          <p:nvPr/>
+        </p:nvSpPr>
+        <p:spPr>
+          <a:xfrm>
+            <a:off x="4828032" y="5212080"/>
+            <a:ext cx="128016" cy="128016"/>
+          </a:xfrm>
+          <a:prstGeom prst="ellipse">
+            <a:avLst/>
+          </a:prstGeom>
+          <a:solidFill>
+            <a:srgbClr val="7C5CFC"/>
+          </a:solidFill>
+          <a:ln/>
+        </p:spPr>
+      </p:sp>
+      <p:sp>
+        <p:nvSpPr>
+          <p:cNvPr id="31" name="Shape 29"/>
+          <p:cNvSpPr/>
+          <p:nvPr/>
+        </p:nvSpPr>
+        <p:spPr>
+          <a:xfrm>
+            <a:off x="8211312" y="2286000"/>
+            <a:ext cx="3529584" cy="3657600"/>
+          </a:xfrm>
+          <a:prstGeom prst="roundRect">
+            <a:avLst>
+              <a:gd name="adj" fmla="val 2591"/>
+            </a:avLst>
+          </a:prstGeom>
+          <a:solidFill>
+            <a:srgbClr val="FFFFFF"/>
+          </a:solidFill>
+          <a:ln w="12700">
+            <a:solidFill>
+              <a:srgbClr val="E4E9F7"/>
+            </a:solidFill>
+            <a:prstDash val="solid"/>
+          </a:ln>
+          <a:effectLst>
+            <a:outerShdw sx="100000" sy="100000" kx="0" ky="0" algn="bl" rotWithShape="0" blurRad="114300" dist="38100" dir="5400000">
+              <a:srgbClr val="0B1437">
+                <a:alpha val="10000"/>
+              </a:srgbClr>
+            </a:outerShdw>
+          </a:effectLst>
+        </p:spPr>
+      </p:sp>
+      <p:sp>
+        <p:nvSpPr>
+          <p:cNvPr id="32" name="Shape 30"/>
+          <p:cNvSpPr/>
+          <p:nvPr/>
+        </p:nvSpPr>
+        <p:spPr>
+          <a:xfrm>
+            <a:off x="8211312" y="2286000"/>
+            <a:ext cx="3529584" cy="128016"/>
+          </a:xfrm>
+          <a:prstGeom prst="rect">
+            <a:avLst/>
+          </a:prstGeom>
+          <a:solidFill>
+            <a:srgbClr val="F0A500"/>
+          </a:solidFill>
+          <a:ln/>
+        </p:spPr>
+      </p:sp>
+      <p:sp>
+        <p:nvSpPr>
+          <p:cNvPr id="33" name="Shape 31"/>
+          <p:cNvSpPr/>
+          <p:nvPr/>
+        </p:nvSpPr>
+        <p:spPr>
+          <a:xfrm>
+            <a:off x="8485632" y="2651760"/>
+            <a:ext cx="658368" cy="658368"/>
+          </a:xfrm>
+          <a:prstGeom prst="ellipse">
+            <a:avLst/>
+          </a:prstGeom>
+          <a:solidFill>
+            <a:srgbClr val="F0A500"/>
+          </a:solidFill>
+          <a:ln/>
+        </p:spPr>
+      </p:sp>
+      <p:sp>
+        <p:nvSpPr>
+          <p:cNvPr id="34" name="Text 32"/>
+          <p:cNvSpPr/>
+          <p:nvPr/>
+        </p:nvSpPr>
+        <p:spPr>
+          <a:xfrm>
+            <a:off x="8485632" y="2651760"/>
+            <a:ext cx="658368" cy="658368"/>
+          </a:xfrm>
+          <a:prstGeom prst="rect">
+            <a:avLst/>
+          </a:prstGeom>
+          <a:noFill/>
+          <a:ln/>
+        </p:spPr>
+        <p:txBody>
+          <a:bodyPr wrap="square" lIns="0" tIns="0" rIns="0" bIns="0" rtlCol="0" anchor="ctr"/>
+          <a:lstStyle/>
+          <a:p>
+            <a:pPr algn="ctr" indent="0" marL="0">
+              <a:buNone/>
+            </a:pPr>
+            <a:r>
+              <a:rPr lang="en-US" sz="3000" b="1" dirty="0">
+                <a:solidFill>
+                  <a:srgbClr val="FFFFFF"/>
+                </a:solidFill>
+                <a:latin typeface="Aptos" pitchFamily="34" charset="0"/>
+                <a:ea typeface="Aptos" pitchFamily="34" charset="-122"/>
+                <a:cs typeface="Aptos" pitchFamily="34" charset="-120"/>
+              </a:rPr>
+              <a:t>3</a:t>
+            </a:r>
+            <a:endParaRPr lang="en-US" sz="3000" dirty="0"/>
+          </a:p>
+        </p:txBody>
+      </p:sp>
+      <p:sp>
+        <p:nvSpPr>
+          <p:cNvPr id="35" name="Text 33"/>
+          <p:cNvSpPr/>
+          <p:nvPr/>
+        </p:nvSpPr>
+        <p:spPr>
+          <a:xfrm>
+            <a:off x="9308592" y="2688336"/>
+            <a:ext cx="2249424" cy="274320"/>
+          </a:xfrm>
+          <a:prstGeom prst="rect">
+            <a:avLst/>
+          </a:prstGeom>
+          <a:noFill/>
+          <a:ln/>
+        </p:spPr>
+        <p:txBody>
+          <a:bodyPr wrap="square" lIns="0" tIns="0" rIns="0" bIns="0" rtlCol="0" anchor="ctr"/>
+          <a:lstStyle/>
+          <a:p>
+            <a:pPr indent="0" marL="0">
+              <a:buNone/>
+            </a:pPr>
+            <a:r>
+              <a:rPr lang="en-US" sz="1200" b="1" spc="200" kern="0" dirty="0">
+                <a:solidFill>
+                  <a:srgbClr val="F0A500"/>
+                </a:solidFill>
+                <a:latin typeface="Aptos" pitchFamily="34" charset="0"/>
+                <a:ea typeface="Aptos" pitchFamily="34" charset="-122"/>
+                <a:cs typeface="Aptos" pitchFamily="34" charset="-120"/>
+              </a:rPr>
+              <a:t>MODEL 3</a:t>
+            </a:r>
+            <a:endParaRPr lang="en-US" sz="1200" dirty="0"/>
+          </a:p>
+        </p:txBody>
+      </p:sp>
+      <p:sp>
+        <p:nvSpPr>
+          <p:cNvPr id="36" name="Text 34"/>
+          <p:cNvSpPr/>
+          <p:nvPr/>
+        </p:nvSpPr>
+        <p:spPr>
+          <a:xfrm>
+            <a:off x="9308592" y="2944368"/>
+            <a:ext cx="2249424" cy="365760"/>
+          </a:xfrm>
+          <a:prstGeom prst="rect">
+            <a:avLst/>
+          </a:prstGeom>
+          <a:noFill/>
+          <a:ln/>
+        </p:spPr>
+        <p:txBody>
+          <a:bodyPr wrap="square" lIns="0" tIns="0" rIns="0" bIns="0" rtlCol="0" anchor="ctr"/>
+          <a:lstStyle/>
+          <a:p>
+            <a:pPr indent="0" marL="0">
+              <a:buNone/>
+            </a:pPr>
+            <a:r>
+              <a:rPr lang="en-US" sz="1900" b="1" dirty="0">
+                <a:solidFill>
+                  <a:srgbClr val="0B1437"/>
+                </a:solidFill>
+                <a:latin typeface="Aptos" pitchFamily="34" charset="0"/>
+                <a:ea typeface="Aptos" pitchFamily="34" charset="-122"/>
+                <a:cs typeface="Aptos" pitchFamily="34" charset="-120"/>
+              </a:rPr>
+              <a:t>Partner-led</a:t>
+            </a:r>
+            <a:endParaRPr lang="en-US" sz="1900" dirty="0"/>
+          </a:p>
+        </p:txBody>
+      </p:sp>
+      <p:sp>
+        <p:nvSpPr>
+          <p:cNvPr id="37" name="Text 35"/>
+          <p:cNvSpPr/>
+          <p:nvPr/>
+        </p:nvSpPr>
+        <p:spPr>
+          <a:xfrm>
+            <a:off x="8485632" y="3566160"/>
+            <a:ext cx="2980944" cy="292608"/>
+          </a:xfrm>
+          <a:prstGeom prst="rect">
+            <a:avLst/>
+          </a:prstGeom>
+          <a:noFill/>
+          <a:ln/>
+        </p:spPr>
+        <p:txBody>
+          <a:bodyPr wrap="square" lIns="0" tIns="0" rIns="0" bIns="0" rtlCol="0" anchor="ctr"/>
+          <a:lstStyle/>
+          <a:p>
+            <a:pPr indent="0" marL="0">
+              <a:buNone/>
+            </a:pPr>
+            <a:r>
+              <a:rPr lang="en-US" sz="1300" b="1" i="1" dirty="0">
+                <a:solidFill>
+                  <a:srgbClr val="8A93B8"/>
+                </a:solidFill>
+                <a:latin typeface="Aptos" pitchFamily="34" charset="0"/>
+                <a:ea typeface="Aptos" pitchFamily="34" charset="-122"/>
+                <a:cs typeface="Aptos" pitchFamily="34" charset="-120"/>
+              </a:rPr>
+              <a:t>When you want a team to own it</a:t>
+            </a:r>
+            <a:endParaRPr lang="en-US" sz="1300" dirty="0"/>
+          </a:p>
+        </p:txBody>
+      </p:sp>
+      <p:sp>
+        <p:nvSpPr>
+          <p:cNvPr id="38" name="Shape 36"/>
+          <p:cNvSpPr/>
+          <p:nvPr/>
+        </p:nvSpPr>
+        <p:spPr>
+          <a:xfrm>
+            <a:off x="8522208" y="4023360"/>
+            <a:ext cx="128016" cy="128016"/>
+          </a:xfrm>
+          <a:prstGeom prst="ellipse">
+            <a:avLst/>
+          </a:prstGeom>
+          <a:solidFill>
+            <a:srgbClr val="F0A500"/>
+          </a:solidFill>
+          <a:ln/>
+        </p:spPr>
+      </p:sp>
+      <p:sp>
+        <p:nvSpPr>
+          <p:cNvPr id="39" name="Text 37"/>
+          <p:cNvSpPr/>
+          <p:nvPr/>
+        </p:nvSpPr>
+        <p:spPr>
+          <a:xfrm>
+            <a:off x="8759952" y="3931920"/>
+            <a:ext cx="2724912" cy="402336"/>
+          </a:xfrm>
+          <a:prstGeom prst="rect">
+            <a:avLst/>
+          </a:prstGeom>
+          <a:noFill/>
+          <a:ln/>
+        </p:spPr>
+        <p:txBody>
+          <a:bodyPr wrap="square" lIns="0" tIns="0" rIns="0" bIns="0" rtlCol="0" anchor="t"/>
+          <a:lstStyle/>
+          <a:p>
+            <a:pPr indent="0" marL="0">
+              <a:lnSpc>
+                <a:spcPct val="104000"/>
+              </a:lnSpc>
+              <a:buNone/>
+            </a:pPr>
+            <a:r>
+              <a:rPr lang="en-US" sz="1200" dirty="0">
+                <a:solidFill>
+                  <a:srgbClr val="43507B"/>
+                </a:solidFill>
+                <a:latin typeface="Aptos" pitchFamily="34" charset="0"/>
+                <a:ea typeface="Aptos" pitchFamily="34" charset="-122"/>
+                <a:cs typeface="Aptos" pitchFamily="34" charset="-120"/>
+              </a:rPr>
+              <a:t>A Microsoft partner runs it</a:t>
+            </a:r>
+            <a:endParaRPr lang="en-US" sz="1200" dirty="0"/>
+          </a:p>
+        </p:txBody>
+      </p:sp>
+      <p:sp>
+        <p:nvSpPr>
+          <p:cNvPr id="40" name="Shape 38"/>
+          <p:cNvSpPr/>
+          <p:nvPr/>
+        </p:nvSpPr>
+        <p:spPr>
+          <a:xfrm>
+            <a:off x="8522208" y="4480560"/>
+            <a:ext cx="128016" cy="128016"/>
+          </a:xfrm>
+          <a:prstGeom prst="ellipse">
+            <a:avLst/>
+          </a:prstGeom>
+          <a:solidFill>
+            <a:srgbClr val="F0A500"/>
+          </a:solidFill>
+          <a:ln/>
+        </p:spPr>
+      </p:sp>
+      <p:sp>
+        <p:nvSpPr>
+          <p:cNvPr id="41" name="Text 39"/>
+          <p:cNvSpPr/>
+          <p:nvPr/>
+        </p:nvSpPr>
+        <p:spPr>
+          <a:xfrm>
+            <a:off x="8759952" y="4389120"/>
+            <a:ext cx="2724912" cy="402336"/>
+          </a:xfrm>
+          <a:prstGeom prst="rect">
+            <a:avLst/>
+          </a:prstGeom>
+          <a:noFill/>
+          <a:ln/>
+        </p:spPr>
+        <p:txBody>
+          <a:bodyPr wrap="square" lIns="0" tIns="0" rIns="0" bIns="0" rtlCol="0" anchor="t"/>
+          <a:lstStyle/>
+          <a:p>
+            <a:pPr indent="0" marL="0">
+              <a:lnSpc>
+                <a:spcPct val="104000"/>
+              </a:lnSpc>
+              <a:buNone/>
+            </a:pPr>
+            <a:r>
+              <a:rPr lang="en-US" sz="1200" dirty="0">
+                <a:solidFill>
+                  <a:srgbClr val="43507B"/>
+                </a:solidFill>
+                <a:latin typeface="Aptos" pitchFamily="34" charset="0"/>
+                <a:ea typeface="Aptos" pitchFamily="34" charset="-122"/>
+                <a:cs typeface="Aptos" pitchFamily="34" charset="-120"/>
+              </a:rPr>
+              <a:t>Delivered and customized for you</a:t>
+            </a:r>
+            <a:endParaRPr lang="en-US" sz="1200" dirty="0"/>
+          </a:p>
+        </p:txBody>
+      </p:sp>
+      <p:sp>
+        <p:nvSpPr>
+          <p:cNvPr id="42" name="Shape 40"/>
+          <p:cNvSpPr/>
+          <p:nvPr/>
+        </p:nvSpPr>
+        <p:spPr>
+          <a:xfrm>
+            <a:off x="8522208" y="4937760"/>
+            <a:ext cx="128016" cy="128016"/>
+          </a:xfrm>
+          <a:prstGeom prst="ellipse">
+            <a:avLst/>
+          </a:prstGeom>
+          <a:solidFill>
+            <a:srgbClr val="F0A500"/>
+          </a:solidFill>
+          <a:ln/>
+        </p:spPr>
+      </p:sp>
+      <p:sp>
+        <p:nvSpPr>
+          <p:cNvPr id="43" name="Text 41"/>
+          <p:cNvSpPr/>
+          <p:nvPr/>
+        </p:nvSpPr>
+        <p:spPr>
+          <a:xfrm>
+            <a:off x="8759952" y="4846320"/>
+            <a:ext cx="2724912" cy="402336"/>
+          </a:xfrm>
+          <a:prstGeom prst="rect">
+            <a:avLst/>
+          </a:prstGeom>
+          <a:noFill/>
+          <a:ln/>
+        </p:spPr>
+        <p:txBody>
+          <a:bodyPr wrap="square" lIns="0" tIns="0" rIns="0" bIns="0" rtlCol="0" anchor="t"/>
+          <a:lstStyle/>
+          <a:p>
+            <a:pPr indent="0" marL="0">
+              <a:lnSpc>
+                <a:spcPct val="104000"/>
+              </a:lnSpc>
+              <a:buNone/>
+            </a:pPr>
+            <a:r>
+              <a:rPr lang="en-US" sz="1200" dirty="0">
+                <a:solidFill>
+                  <a:srgbClr val="43507B"/>
+                </a:solidFill>
+                <a:latin typeface="Aptos" pitchFamily="34" charset="0"/>
+                <a:ea typeface="Aptos" pitchFamily="34" charset="-122"/>
+                <a:cs typeface="Aptos" pitchFamily="34" charset="-120"/>
+              </a:rPr>
+              <a:t>They own rollout and adoption</a:t>
+            </a:r>
+            <a:endParaRPr lang="en-US" sz="1200" dirty="0"/>
+          </a:p>
+        </p:txBody>
+      </p:sp>
+      <p:sp>
+        <p:nvSpPr>
+          <p:cNvPr id="44" name="Text 42"/>
+          <p:cNvSpPr/>
+          <p:nvPr/>
+        </p:nvSpPr>
+        <p:spPr>
+          <a:xfrm>
+            <a:off x="640080" y="6419088"/>
+            <a:ext cx="8229600" cy="274320"/>
+          </a:xfrm>
+          <a:prstGeom prst="rect">
+            <a:avLst/>
+          </a:prstGeom>
+          <a:noFill/>
+          <a:ln/>
+        </p:spPr>
+        <p:txBody>
+          <a:bodyPr wrap="square" lIns="0" tIns="0" rIns="0" bIns="0" rtlCol="0" anchor="ctr"/>
+          <a:lstStyle/>
+          <a:p>
+            <a:pPr algn="l" indent="0" marL="0">
+              <a:buNone/>
+            </a:pPr>
+            <a:r>
+              <a:rPr lang="en-US" sz="900" dirty="0">
+                <a:solidFill>
+                  <a:srgbClr val="8A93B8"/>
+                </a:solidFill>
+                <a:latin typeface="Aptos" pitchFamily="34" charset="0"/>
+                <a:ea typeface="Aptos" pitchFamily="34" charset="-122"/>
+                <a:cs typeface="Aptos" pitchFamily="34" charset="-120"/>
+              </a:rPr>
+              <a:t>Microsoft 365 Copilot Premium  ·  Executive Working Session</a:t>
+            </a:r>
+            <a:endParaRPr lang="en-US" sz="900" dirty="0"/>
+          </a:p>
+        </p:txBody>
+      </p:sp>
+      <p:sp>
+        <p:nvSpPr>
+          <p:cNvPr id="45" name="Text 43"/>
+          <p:cNvSpPr/>
+          <p:nvPr/>
+        </p:nvSpPr>
+        <p:spPr>
+          <a:xfrm>
+            <a:off x="11155680" y="6419088"/>
+            <a:ext cx="640080" cy="274320"/>
+          </a:xfrm>
+          <a:prstGeom prst="rect">
+            <a:avLst/>
+          </a:prstGeom>
+          <a:noFill/>
+          <a:ln/>
+        </p:spPr>
+        <p:txBody>
+          <a:bodyPr wrap="square" lIns="0" tIns="0" rIns="0" bIns="0" rtlCol="0" anchor="ctr"/>
+          <a:lstStyle/>
+          <a:p>
+            <a:pPr algn="r" indent="0" marL="0">
+              <a:buNone/>
+            </a:pPr>
+            <a:r>
+              <a:rPr lang="en-US" sz="900" dirty="0">
+                <a:solidFill>
+                  <a:srgbClr val="8A93B8"/>
+                </a:solidFill>
+                <a:latin typeface="Aptos" pitchFamily="34" charset="0"/>
+                <a:ea typeface="Aptos" pitchFamily="34" charset="-122"/>
+                <a:cs typeface="Aptos" pitchFamily="34" charset="-120"/>
+              </a:rPr>
+              <a:t>26</a:t>
+            </a:r>
+            <a:endParaRPr lang="en-US" sz="900" dirty="0"/>
           </a:p>
         </p:txBody>
       </p:sp>

</xml_diff>